<commit_message>
Traspaso al Sprint 2: CLAUDE.md, guia de trabajo, herramientas y scripts del dataset preparado
- CLAUDE.md y docs/TRASPASO_SPRINT2.md: estado, plan, entorno y versiones
- dataset preparado: preparar_dataset.py y verificar_preparado.py; perfil_datos.py
- informe del Sprint 1 en Word y PDF, presentaciones con diseño claro (29 diapositivas)
- notebooks del Sprint 1 con paleta sobria; carpeta del Sprint 2 y herramientas

Co-Authored-By: Claude Sonnet 5.5 <noreply@anthropic.com>
</commit_message>
<xml_diff>
--- a/01. Inicio/Planificación de Lanzamiento.pptx
+++ b/01. Inicio/Planificación de Lanzamiento.pptx
@@ -22593,7 +22593,7 @@
             <a:avLst/>
           </a:prstGeom>
           <a:solidFill>
-            <a:srgbClr val="ED7D31"/>
+            <a:srgbClr val="5B84B1"/>
           </a:solidFill>
           <a:ln>
             <a:noFill/>
@@ -22839,7 +22839,7 @@
             <a:avLst/>
           </a:prstGeom>
           <a:solidFill>
-            <a:srgbClr val="C00000"/>
+            <a:srgbClr val="8C2F39"/>
           </a:solidFill>
           <a:ln>
             <a:noFill/>
@@ -22884,7 +22884,7 @@
           </a:prstGeom>
           <a:ln w="9525">
             <a:solidFill>
-              <a:srgbClr val="C00000"/>
+              <a:srgbClr val="8C2F39"/>
             </a:solidFill>
           </a:ln>
         </p:spPr>
@@ -22965,7 +22965,7 @@
             <a:avLst/>
           </a:prstGeom>
           <a:solidFill>
-            <a:srgbClr val="C00000"/>
+            <a:srgbClr val="8C2F39"/>
           </a:solidFill>
           <a:ln>
             <a:noFill/>
@@ -23010,7 +23010,7 @@
           </a:prstGeom>
           <a:ln w="9525">
             <a:solidFill>
-              <a:srgbClr val="C00000"/>
+              <a:srgbClr val="8C2F39"/>
             </a:solidFill>
           </a:ln>
         </p:spPr>
@@ -23091,7 +23091,7 @@
             <a:avLst/>
           </a:prstGeom>
           <a:solidFill>
-            <a:srgbClr val="C00000"/>
+            <a:srgbClr val="8C2F39"/>
           </a:solidFill>
           <a:ln>
             <a:noFill/>
@@ -23136,7 +23136,7 @@
           </a:prstGeom>
           <a:ln w="9525">
             <a:solidFill>
-              <a:srgbClr val="C00000"/>
+              <a:srgbClr val="8C2F39"/>
             </a:solidFill>
           </a:ln>
         </p:spPr>
@@ -23462,7 +23462,7 @@
         </p:nvCxnSpPr>
         <p:spPr>
           <a:xfrm>
-            <a:off x="5000105" y="1682496"/>
+            <a:off x="6510250" y="1682496"/>
             <a:ext cx="0" cy="3072384"/>
           </a:xfrm>
           <a:prstGeom prst="line">
@@ -23470,7 +23470,7 @@
           </a:prstGeom>
           <a:ln w="19050">
             <a:solidFill>
-              <a:srgbClr val="C00000"/>
+              <a:srgbClr val="8C2F39"/>
             </a:solidFill>
             <a:prstDash val="dash"/>
           </a:ln>
@@ -23498,14 +23498,14 @@
         </p:nvSpPr>
         <p:spPr>
           <a:xfrm>
-            <a:off x="4634345" y="1901952"/>
+            <a:off x="6144490" y="1901952"/>
             <a:ext cx="731520" cy="201168"/>
           </a:xfrm>
           <a:prstGeom prst="rect">
             <a:avLst/>
           </a:prstGeom>
           <a:solidFill>
-            <a:srgbClr val="C00000"/>
+            <a:srgbClr val="8C2F39"/>
           </a:solidFill>
           <a:ln>
             <a:noFill/>
@@ -23538,7 +23538,7 @@
                 </a:solidFill>
                 <a:latin typeface="Calibri"/>
               </a:rPr>
-              <a:t>Hoy 11 oct</a:t>
+              <a:t>Hoy 16 oct</a:t>
             </a:r>
           </a:p>
         </p:txBody>

</xml_diff>